<commit_message>
fix: format mathematical equations cleanly across README, presentation, PDF report, and Streamlit app
</commit_message>
<xml_diff>
--- a/reports/Molecular_Graph_Classification_Presentation.pptx
+++ b/reports/Molecular_Graph_Classification_Presentation.pptx
@@ -4834,7 +4834,7 @@
           <a:p>
             <a:pPr>
               <a:spcAft>
-                <a:spcPts val="1000"/>
+                <a:spcPts val="800"/>
               </a:spcAft>
               <a:defRPr sz="1600" b="1">
                 <a:solidFill>
@@ -4848,42 +4848,93 @@
           </a:p>
           <a:p>
             <a:pPr>
-              <a:defRPr sz="1200">
+              <a:spcAft>
+                <a:spcPts val="600"/>
+              </a:spcAft>
+              <a:defRPr sz="1150">
                 <a:solidFill>
                   <a:srgbClr val="1E293B"/>
                 </a:solidFill>
               </a:defRPr>
             </a:pPr>
             <a:r>
-              <a:t>1. Initialization (t=0): Assign initial categorical label l_0(v) from atom type.</a:t>
-            </a:r>
-            <a:br/>
-            <a:br/>
-            <a:r>
-              <a:t>2. Neighborhood Multiset Aggregation: Collect neighbor labels:</a:t>
-            </a:r>
-            <a:br/>
-            <a:r>
-              <a:t>   M_t(v) = {{ l_{t-1}(u) : u in N(v) }}</a:t>
-            </a:r>
-            <a:br/>
-            <a:br/>
-            <a:r>
-              <a:t>3. Deterministic Sorting &amp; Hash Compression: Sort M_t(v) and map tuple</a:t>
-            </a:r>
-            <a:br/>
-            <a:r>
-              <a:t>   (t, l_{t-1}(v), sort(M_t(v))) -&gt; unique compressed ID.</a:t>
-            </a:r>
-            <a:br/>
-            <a:br/>
-            <a:r>
-              <a:t>4. Subtree Count Histogram: Count frequencies of discovered subtree patterns.</a:t>
-            </a:r>
-            <a:br/>
-            <a:br/>
-            <a:r>
-              <a:t>5. Kernel Inner Product: K(G_i, G_j) = &lt; phi(G_i), phi(G_j) &gt; with cosine normalization.</a:t>
+              <a:t>1. Initialization (t = 0): Assign each atom its categorical label ℓ₀(v) = atom_type(v).</a:t>
+            </a:r>
+          </a:p>
+          <a:p>
+            <a:pPr>
+              <a:spcAft>
+                <a:spcPts val="600"/>
+              </a:spcAft>
+              <a:defRPr sz="1150">
+                <a:solidFill>
+                  <a:srgbClr val="1E293B"/>
+                </a:solidFill>
+              </a:defRPr>
+            </a:pPr>
+            <a:r>
+              <a:t>2. Neighborhood Multiset Aggregation: For each atom v, gather neighbor labels:</a:t>
+            </a:r>
+            <a:br/>
+            <a:r>
+              <a:t>   𝓡_t(v) = { ℓ_{t-1}(u) : u ∈ 𝒩(v) }</a:t>
+            </a:r>
+          </a:p>
+          <a:p>
+            <a:pPr>
+              <a:spcAft>
+                <a:spcPts val="600"/>
+              </a:spcAft>
+              <a:defRPr sz="1150">
+                <a:solidFill>
+                  <a:srgbClr val="1E293B"/>
+                </a:solidFill>
+              </a:defRPr>
+            </a:pPr>
+            <a:r>
+              <a:t>3. Deterministic Sorting &amp; Hash Compression:</a:t>
+            </a:r>
+            <a:br/>
+            <a:r>
+              <a:t>   ℓ_t(v) = hash( t, ℓ_{t-1}(v), sort(𝓡_t(v)) )</a:t>
+            </a:r>
+          </a:p>
+          <a:p>
+            <a:pPr>
+              <a:spcAft>
+                <a:spcPts val="600"/>
+              </a:spcAft>
+              <a:defRPr sz="1150">
+                <a:solidFill>
+                  <a:srgbClr val="1E293B"/>
+                </a:solidFill>
+              </a:defRPr>
+            </a:pPr>
+            <a:r>
+              <a:t>4. Subtree Histogram Counting: Compute occurrence counts of all discovered subtree labels:</a:t>
+            </a:r>
+            <a:br/>
+            <a:r>
+              <a:t>   ϕ_t(G) = [ c(G, σ₁)  c(G, σ₂) … c(G, σ_{|Σ_t|}) ]ᵀ</a:t>
+            </a:r>
+          </a:p>
+          <a:p>
+            <a:pPr>
+              <a:spcAft>
+                <a:spcPts val="600"/>
+              </a:spcAft>
+              <a:defRPr sz="1150">
+                <a:solidFill>
+                  <a:srgbClr val="1E293B"/>
+                </a:solidFill>
+              </a:defRPr>
+            </a:pPr>
+            <a:r>
+              <a:t>5. Kernel Gram Matrix: Evaluate inner products with cosine normalization:</a:t>
+            </a:r>
+            <a:br/>
+            <a:r>
+              <a:t>   K_norm(Gᵢ, Gⱼ) = ⟨ϕ(Gᵢ), ϕ(Gⱼ)⟩ / ( ‖ϕ(Gᵢ)‖₂ · ‖ϕ(Gⱼ)‖₂ )</a:t>
             </a:r>
           </a:p>
         </p:txBody>
@@ -4971,45 +5022,77 @@
           </a:p>
           <a:p>
             <a:pPr>
-              <a:defRPr sz="1200">
+              <a:spcAft>
+                <a:spcPts val="500"/>
+              </a:spcAft>
+              <a:defRPr sz="1150">
                 <a:solidFill>
                   <a:srgbClr val="1E293B"/>
                 </a:solidFill>
               </a:defRPr>
             </a:pPr>
             <a:r>
-              <a:t>• Scratch Implementation:</a:t>
-            </a:r>
-            <a:br/>
-            <a:r>
-              <a:t>  Strictly manual in src/wl_kernel.py without GraKeL or NetworkX kernel tools.</a:t>
-            </a:r>
-            <a:br/>
-            <a:br/>
-            <a:r>
-              <a:t>• Time Complexity:</a:t>
-            </a:r>
-            <a:br/>
-            <a:r>
-              <a:t>  O(h * N * m) for feature extraction across N graphs with m edges.</a:t>
-            </a:r>
-            <a:br/>
-            <a:br/>
-            <a:r>
-              <a:t>• Sparse Gram Matrix:</a:t>
-            </a:r>
-            <a:br/>
-            <a:r>
-              <a:t>  Constructed using scipy.sparse.csr_matrix to ensure high memory efficiency.</a:t>
-            </a:r>
-            <a:br/>
-            <a:br/>
-            <a:r>
-              <a:t>• Zero Data Leakage:</a:t>
-            </a:r>
-            <a:br/>
-            <a:r>
-              <a:t>  Vocabulary fitted on training graphs only; K_test_train (N_test x N_train) evaluated properly.</a:t>
+              <a:t>• Scratch Implementation: Strictly manual in src/wl_kernel.py without GraKeL or NetworkX kernel tools.</a:t>
+            </a:r>
+          </a:p>
+          <a:p>
+            <a:pPr>
+              <a:spcAft>
+                <a:spcPts val="500"/>
+              </a:spcAft>
+              <a:defRPr sz="1150">
+                <a:solidFill>
+                  <a:srgbClr val="1E293B"/>
+                </a:solidFill>
+              </a:defRPr>
+            </a:pPr>
+            <a:r>
+              <a:t>• Time Complexity: 𝒪(h · N · m) for feature extraction across N graphs with m edges.</a:t>
+            </a:r>
+          </a:p>
+          <a:p>
+            <a:pPr>
+              <a:spcAft>
+                <a:spcPts val="500"/>
+              </a:spcAft>
+              <a:defRPr sz="1150">
+                <a:solidFill>
+                  <a:srgbClr val="1E293B"/>
+                </a:solidFill>
+              </a:defRPr>
+            </a:pPr>
+            <a:r>
+              <a:t>• Memory &amp; Sparse Matrix: Uses scipy.sparse.csr_matrix with space bounded by 𝒪(N · n · h).</a:t>
+            </a:r>
+          </a:p>
+          <a:p>
+            <a:pPr>
+              <a:spcAft>
+                <a:spcPts val="500"/>
+              </a:spcAft>
+              <a:defRPr sz="1150">
+                <a:solidFill>
+                  <a:srgbClr val="1E293B"/>
+                </a:solidFill>
+              </a:defRPr>
+            </a:pPr>
+            <a:r>
+              <a:t>• Mercer Guarantee: K is proven symmetric (K = Kᵀ) and positive semi-definite (λᵢ ≥ 0).</a:t>
+            </a:r>
+          </a:p>
+          <a:p>
+            <a:pPr>
+              <a:spcAft>
+                <a:spcPts val="500"/>
+              </a:spcAft>
+              <a:defRPr sz="1150">
+                <a:solidFill>
+                  <a:srgbClr val="1E293B"/>
+                </a:solidFill>
+              </a:defRPr>
+            </a:pPr>
+            <a:r>
+              <a:t>• Zero Data Leakage: Vocabulary fitted solely on train graphs; K_test_train (N_test × N_train) evaluated properly.</a:t>
             </a:r>
           </a:p>
         </p:txBody>
@@ -5230,7 +5313,7 @@
           </a:p>
           <a:p>
             <a:pPr>
-              <a:defRPr sz="1250">
+              <a:defRPr sz="1200">
                 <a:solidFill>
                   <a:srgbClr val="1E293B"/>
                 </a:solidFill>
@@ -5242,20 +5325,20 @@
             <a:br/>
             <a:br/>
             <a:r>
-              <a:t>• Graph A (C3 Cycle): Triangle 0-1, 1-2, 2-0</a:t>
-            </a:r>
-            <a:br/>
-            <a:r>
-              <a:t>  Each atom has degree 2.</a:t>
-            </a:r>
-            <a:br/>
-            <a:br/>
-            <a:r>
-              <a:t>• Graph B (P3 Path): Linear chain 0-1, 1-2</a:t>
-            </a:r>
-            <a:br/>
-            <a:r>
-              <a:t>  Atoms have degrees 1, 2, 1.</a:t>
+              <a:t>• Graph A (C₃ Cycle): Triangle edges (0-1, 1-2, 2-0)</a:t>
+            </a:r>
+            <a:br/>
+            <a:r>
+              <a:t>  Every atom has degree = 2.</a:t>
+            </a:r>
+            <a:br/>
+            <a:br/>
+            <a:r>
+              <a:t>• Graph B (P₃ Path): Linear chain edges (0-1, 1-2)</a:t>
+            </a:r>
+            <a:br/>
+            <a:r>
+              <a:t>  Endpoint atoms have degree = 1; center atom has degree = 2.</a:t>
             </a:r>
             <a:br/>
             <a:br/>
@@ -5264,11 +5347,11 @@
             </a:r>
             <a:br/>
             <a:r>
-              <a:t>Both graphs produce identical feature vectors: phi_0 = [3]</a:t>
-            </a:r>
-            <a:br/>
-            <a:r>
-              <a:t>The naive 'bag of atoms' model cannot tell them apart!</a:t>
+              <a:t>Both graphs produce identical feature vectors: ϕ₀ = [3.0]</a:t>
+            </a:r>
+            <a:br/>
+            <a:r>
+              <a:t>A naive 'bag of atoms' model cannot tell them apart!</a:t>
             </a:r>
           </a:p>
         </p:txBody>
@@ -5356,36 +5439,36 @@
           </a:p>
           <a:p>
             <a:pPr>
-              <a:defRPr sz="1250">
+              <a:defRPr sz="1200">
                 <a:solidFill>
                   <a:srgbClr val="1E293B"/>
                 </a:solidFill>
               </a:defRPr>
             </a:pPr>
             <a:r>
-              <a:t>Neighborhood Multiset Signatures at h = 1:</a:t>
-            </a:r>
-            <a:br/>
-            <a:br/>
-            <a:r>
-              <a:t>• For C3: All 3 nodes have signature (1, 0, (0, 0)) -&gt; ID 1</a:t>
-            </a:r>
-            <a:br/>
-            <a:r>
-              <a:t>  phi(C3) = [3, 3, 0]</a:t>
-            </a:r>
-            <a:br/>
-            <a:br/>
-            <a:r>
-              <a:t>• For P3: Center node has signature (1, 0, (0, 0)) -&gt; ID 1</a:t>
-            </a:r>
-            <a:br/>
-            <a:r>
-              <a:t>  Two leaf nodes have signature (1, 0, (0,)) -&gt; ID 2</a:t>
-            </a:r>
-            <a:br/>
-            <a:r>
-              <a:t>  phi(P3) = [3, 1, 2]</a:t>
+              <a:t>Neighborhood Signatures at h = 1:</a:t>
+            </a:r>
+            <a:br/>
+            <a:br/>
+            <a:r>
+              <a:t>• For C₃: All 3 nodes have signature (1, 0, (0, 0)) → ID 1</a:t>
+            </a:r>
+            <a:br/>
+            <a:r>
+              <a:t>  ϕ(C₃) = [3, 3, 0]ᵀ</a:t>
+            </a:r>
+            <a:br/>
+            <a:br/>
+            <a:r>
+              <a:t>• For P₃: Center node signature (1, 0, (0, 0)) → ID 1</a:t>
+            </a:r>
+            <a:br/>
+            <a:r>
+              <a:t>  Two endpoints signature (1, 0, (0,)) → ID 2</a:t>
+            </a:r>
+            <a:br/>
+            <a:r>
+              <a:t>  ϕ(P₃) = [3, 1, 2]ᵀ</a:t>
             </a:r>
             <a:br/>
             <a:br/>
@@ -5394,16 +5477,20 @@
             </a:r>
             <a:br/>
             <a:r>
-              <a:t>  K = [[18, 12],</a:t>
-            </a:r>
-            <a:br/>
-            <a:r>
-              <a:t>       [12, 14]]</a:t>
-            </a:r>
-            <a:br/>
-            <a:br/>
-            <a:r>
-              <a:t>Conclusion: 1-WL successfully separates the cycle from the path!</a:t>
+              <a:t>  K = ⎡ 18   12 ⎤</a:t>
+            </a:r>
+            <a:br/>
+            <a:r>
+              <a:t>      ⎣ 12   14 ⎦</a:t>
+            </a:r>
+            <a:br/>
+            <a:br/>
+            <a:r>
+              <a:t>Normalized similarity: 12 / √(18 · 14) = 0.7559 &lt; 1.0</a:t>
+            </a:r>
+            <a:br/>
+            <a:r>
+              <a:t>1-WL successfully separates the cycle from the path!</a:t>
             </a:r>
           </a:p>
         </p:txBody>

</xml_diff>

<commit_message>
docs: update course to Machine Learning with graphs (23CSE479) and core method to Weisfeiler-Lehman kernel across app, PPT, PDF, and docs
</commit_message>
<xml_diff>
--- a/reports/Molecular_Graph_Classification_Presentation.pptx
+++ b/reports/Molecular_Graph_Classification_Presentation.pptx
@@ -3177,7 +3177,7 @@
               </a:defRPr>
             </a:pPr>
             <a:r>
-              <a:t>ACADEMIC ASSESSMENT | GRAPH REPRESENTATION LEARNING</a:t>
+              <a:t>MACHINE LEARNING WITH GRAPHS | COURSE CODE: 23CSE479</a:t>
             </a:r>
           </a:p>
           <a:p>
@@ -3280,7 +3280,7 @@
               </a:defRPr>
             </a:pPr>
             <a:r>
-              <a:t>GRAPH REPRESENTATION LEARNING</a:t>
+              <a:t>MACHINE LEARNING WITH GRAPHS (23CSE479)</a:t>
             </a:r>
           </a:p>
         </p:txBody>
@@ -3659,7 +3659,7 @@
               </a:defRPr>
             </a:pPr>
             <a:r>
-              <a:t>GRAPH REPRESENTATION LEARNING</a:t>
+              <a:t>MACHINE LEARNING WITH GRAPHS (23CSE479)</a:t>
             </a:r>
           </a:p>
         </p:txBody>
@@ -4219,7 +4219,7 @@
               </a:defRPr>
             </a:pPr>
             <a:r>
-              <a:t>GRAPH REPRESENTATION LEARNING</a:t>
+              <a:t>MACHINE LEARNING WITH GRAPHS (23CSE479)</a:t>
             </a:r>
           </a:p>
         </p:txBody>
@@ -4680,7 +4680,7 @@
               </a:defRPr>
             </a:pPr>
             <a:r>
-              <a:t>GRAPH REPRESENTATION LEARNING</a:t>
+              <a:t>MACHINE LEARNING WITH GRAPHS (23CSE479)</a:t>
             </a:r>
           </a:p>
         </p:txBody>
@@ -5145,7 +5145,7 @@
               </a:defRPr>
             </a:pPr>
             <a:r>
-              <a:t>GRAPH REPRESENTATION LEARNING</a:t>
+              <a:t>MACHINE LEARNING WITH GRAPHS (23CSE479)</a:t>
             </a:r>
           </a:p>
         </p:txBody>
@@ -5543,7 +5543,7 @@
               </a:defRPr>
             </a:pPr>
             <a:r>
-              <a:t>GRAPH REPRESENTATION LEARNING</a:t>
+              <a:t>MACHINE LEARNING WITH GRAPHS (23CSE479)</a:t>
             </a:r>
           </a:p>
         </p:txBody>
@@ -6211,7 +6211,7 @@
               </a:defRPr>
             </a:pPr>
             <a:r>
-              <a:t>GRAPH REPRESENTATION LEARNING</a:t>
+              <a:t>MACHINE LEARNING WITH GRAPHS (23CSE479)</a:t>
             </a:r>
           </a:p>
         </p:txBody>
@@ -7354,7 +7354,7 @@
               </a:defRPr>
             </a:pPr>
             <a:r>
-              <a:t>GRAPH REPRESENTATION LEARNING</a:t>
+              <a:t>MACHINE LEARNING WITH GRAPHS (23CSE479)</a:t>
             </a:r>
           </a:p>
         </p:txBody>
@@ -7741,7 +7741,7 @@
               </a:defRPr>
             </a:pPr>
             <a:r>
-              <a:t>GRAPH REPRESENTATION LEARNING</a:t>
+              <a:t>MACHINE LEARNING WITH GRAPHS (23CSE479)</a:t>
             </a:r>
           </a:p>
         </p:txBody>
@@ -8100,7 +8100,7 @@
               </a:defRPr>
             </a:pPr>
             <a:r>
-              <a:t>GRAPH REPRESENTATION LEARNING</a:t>
+              <a:t>MACHINE LEARNING WITH GRAPHS (23CSE479)</a:t>
             </a:r>
           </a:p>
         </p:txBody>

</xml_diff>